<commit_message>
format updated in PPT
</commit_message>
<xml_diff>
--- a/Presentation1.pptx
+++ b/Presentation1.pptx
@@ -3144,77 +3144,6 @@
           </a:p>
         </p:txBody>
       </p:sp>
-      <p:sp>
-        <p:nvSpPr>
-          <p:cNvPr id="18" name="TextBox 17"/>
-          <p:cNvSpPr txBox="1"/>
-          <p:nvPr/>
-        </p:nvSpPr>
-        <p:spPr>
-          <a:xfrm>
-            <a:off x="1219167" y="1148789"/>
-            <a:ext cx="1923221" cy="215444"/>
-          </a:xfrm>
-          <a:prstGeom prst="rect">
-            <a:avLst/>
-          </a:prstGeom>
-          <a:noFill/>
-        </p:spPr>
-        <p:txBody>
-          <a:bodyPr wrap="square" rtlCol="0">
-            <a:spAutoFit/>
-          </a:bodyPr>
-          <a:lstStyle/>
-          <a:p>
-            <a:pPr algn="ctr"/>
-            <a:r>
-              <a:rPr lang="hi-IN" sz="800" dirty="0" smtClean="0">
-                <a:solidFill>
-                  <a:srgbClr val="5B6C37"/>
-                </a:solidFill>
-              </a:rPr>
-              <a:t>शुद्ध</a:t>
-            </a:r>
-            <a:r>
-              <a:rPr lang="en-US" sz="800" dirty="0" smtClean="0">
-                <a:solidFill>
-                  <a:srgbClr val="5B6C37"/>
-                </a:solidFill>
-              </a:rPr>
-              <a:t> </a:t>
-            </a:r>
-            <a:r>
-              <a:rPr lang="hi-IN" sz="800" dirty="0" smtClean="0">
-                <a:solidFill>
-                  <a:srgbClr val="5B6C37"/>
-                </a:solidFill>
-              </a:rPr>
-              <a:t> • सात्विक </a:t>
-            </a:r>
-            <a:r>
-              <a:rPr lang="en-US" sz="800" dirty="0" smtClean="0">
-                <a:solidFill>
-                  <a:srgbClr val="5B6C37"/>
-                </a:solidFill>
-              </a:rPr>
-              <a:t> </a:t>
-            </a:r>
-            <a:r>
-              <a:rPr lang="hi-IN" sz="800" dirty="0" smtClean="0">
-                <a:solidFill>
-                  <a:srgbClr val="5B6C37"/>
-                </a:solidFill>
-              </a:rPr>
-              <a:t>• शाकाहारी खाना</a:t>
-            </a:r>
-            <a:endParaRPr lang="en-US" sz="800" dirty="0">
-              <a:solidFill>
-                <a:srgbClr val="5B6C37"/>
-              </a:solidFill>
-            </a:endParaRPr>
-          </a:p>
-        </p:txBody>
-      </p:sp>
       <p:cxnSp>
         <p:nvCxnSpPr>
           <p:cNvPr id="23" name="Straight Connector 22"/>
@@ -3258,8 +3187,8 @@
         </p:nvSpPr>
         <p:spPr>
           <a:xfrm>
-            <a:off x="1600200" y="1322811"/>
-            <a:ext cx="942887" cy="215444"/>
+            <a:off x="1575668" y="1166419"/>
+            <a:ext cx="1039067" cy="215444"/>
           </a:xfrm>
           <a:prstGeom prst="rect">
             <a:avLst/>
@@ -3273,13 +3202,40 @@
           <a:lstStyle/>
           <a:p>
             <a:r>
+              <a:rPr lang="en-US" sz="800" i="1" dirty="0">
+                <a:solidFill>
+                  <a:srgbClr val="7E603A"/>
+                </a:solidFill>
+                <a:latin typeface="Georgia" panose="02040502050405020303" pitchFamily="18" charset="0"/>
+              </a:rPr>
+              <a:t> </a:t>
+            </a:r>
+            <a:r>
               <a:rPr lang="en-US" sz="800" i="1" dirty="0" smtClean="0">
                 <a:solidFill>
                   <a:srgbClr val="7E603A"/>
                 </a:solidFill>
                 <a:latin typeface="Georgia" panose="02040502050405020303" pitchFamily="18" charset="0"/>
               </a:rPr>
-              <a:t>Homemade food</a:t>
+              <a:t>   </a:t>
+            </a:r>
+            <a:r>
+              <a:rPr lang="en-US" sz="800" i="1" dirty="0" smtClean="0">
+                <a:solidFill>
+                  <a:srgbClr val="7E603A"/>
+                </a:solidFill>
+                <a:latin typeface="Georgia" panose="02040502050405020303" pitchFamily="18" charset="0"/>
+              </a:rPr>
+              <a:t>Homemade </a:t>
+            </a:r>
+            <a:r>
+              <a:rPr lang="en-US" sz="800" i="1" dirty="0" smtClean="0">
+                <a:solidFill>
+                  <a:srgbClr val="7E603A"/>
+                </a:solidFill>
+                <a:latin typeface="Georgia" panose="02040502050405020303" pitchFamily="18" charset="0"/>
+              </a:rPr>
+              <a:t>food</a:t>
             </a:r>
             <a:endParaRPr lang="en-US" sz="800" i="1" dirty="0">
               <a:solidFill>
@@ -3400,8 +3356,8 @@
         </p:nvSpPr>
         <p:spPr>
           <a:xfrm>
-            <a:off x="1108904" y="100922"/>
-            <a:ext cx="872158" cy="276999"/>
+            <a:off x="1136729" y="129954"/>
+            <a:ext cx="872158" cy="246221"/>
           </a:xfrm>
           <a:prstGeom prst="rect">
             <a:avLst/>
@@ -3415,17 +3371,17 @@
           <a:lstStyle/>
           <a:p>
             <a:r>
-              <a:rPr lang="en-US" sz="1200" dirty="0" smtClean="0">
+              <a:rPr lang="en-US" sz="1000" dirty="0" smtClean="0">
                 <a:solidFill>
-                  <a:srgbClr val="7E0000"/>
+                  <a:srgbClr val="7E603A"/>
                 </a:solidFill>
                 <a:latin typeface="Georgia" panose="02040502050405020303" pitchFamily="18" charset="0"/>
               </a:rPr>
               <a:t>Address :</a:t>
             </a:r>
-            <a:endParaRPr lang="en-US" sz="1200" dirty="0">
+            <a:endParaRPr lang="en-US" sz="1000" dirty="0">
               <a:solidFill>
-                <a:srgbClr val="7E0000"/>
+                <a:srgbClr val="7E603A"/>
               </a:solidFill>
               <a:latin typeface="Georgia" panose="02040502050405020303" pitchFamily="18" charset="0"/>
             </a:endParaRPr>
@@ -3461,12 +3417,15 @@
         </p:blipFill>
         <p:spPr>
           <a:xfrm>
-            <a:off x="1029628" y="183177"/>
+            <a:off x="1043683" y="182569"/>
             <a:ext cx="93046" cy="133521"/>
           </a:xfrm>
           <a:prstGeom prst="rect">
             <a:avLst/>
           </a:prstGeom>
+          <a:ln>
+            <a:noFill/>
+          </a:ln>
         </p:spPr>
       </p:pic>
       <p:sp>
@@ -3477,8 +3436,8 @@
         </p:nvSpPr>
         <p:spPr>
           <a:xfrm>
-            <a:off x="1110684" y="341065"/>
-            <a:ext cx="1677229" cy="369332"/>
+            <a:off x="1108904" y="480132"/>
+            <a:ext cx="1677229" cy="491288"/>
           </a:xfrm>
           <a:prstGeom prst="rect">
             <a:avLst/>
@@ -3491,23 +3450,48 @@
           </a:bodyPr>
           <a:lstStyle/>
           <a:p>
+            <a:pPr>
+              <a:lnSpc>
+                <a:spcPct val="150000"/>
+              </a:lnSpc>
+            </a:pPr>
             <a:r>
               <a:rPr lang="en-US" sz="600" b="1" dirty="0" smtClean="0">
                 <a:solidFill>
                   <a:srgbClr val="5B6C37"/>
                 </a:solidFill>
-                <a:latin typeface="Arial" panose="020B0604020202020204" pitchFamily="34" charset="0"/>
-                <a:cs typeface="Arial" panose="020B0604020202020204" pitchFamily="34" charset="0"/>
+                <a:latin typeface="Times New Roman" panose="02020603050405020304" pitchFamily="18" charset="0"/>
+                <a:cs typeface="Times New Roman" panose="02020603050405020304" pitchFamily="18" charset="0"/>
               </a:rPr>
-              <a:t>House no. 129, Street no.: 3,Sector: 24, Block: </a:t>
+              <a:t>House no. 129, Street no.: 3</a:t>
             </a:r>
             <a:r>
               <a:rPr lang="en-US" sz="600" b="1" dirty="0" smtClean="0">
                 <a:solidFill>
                   <a:srgbClr val="5B6C37"/>
                 </a:solidFill>
-                <a:latin typeface="Arial" panose="020B0604020202020204" pitchFamily="34" charset="0"/>
-                <a:cs typeface="Arial" panose="020B0604020202020204" pitchFamily="34" charset="0"/>
+                <a:latin typeface="Times New Roman" panose="02020603050405020304" pitchFamily="18" charset="0"/>
+                <a:cs typeface="Times New Roman" panose="02020603050405020304" pitchFamily="18" charset="0"/>
+              </a:rPr>
+              <a:t>, Sector</a:t>
+            </a:r>
+            <a:r>
+              <a:rPr lang="en-US" sz="600" b="1" dirty="0" smtClean="0">
+                <a:solidFill>
+                  <a:srgbClr val="5B6C37"/>
+                </a:solidFill>
+                <a:latin typeface="Times New Roman" panose="02020603050405020304" pitchFamily="18" charset="0"/>
+                <a:cs typeface="Times New Roman" panose="02020603050405020304" pitchFamily="18" charset="0"/>
+              </a:rPr>
+              <a:t>: 24, Block: </a:t>
+            </a:r>
+            <a:r>
+              <a:rPr lang="en-US" sz="600" b="1" dirty="0" smtClean="0">
+                <a:solidFill>
+                  <a:srgbClr val="5B6C37"/>
+                </a:solidFill>
+                <a:latin typeface="Times New Roman" panose="02020603050405020304" pitchFamily="18" charset="0"/>
+                <a:cs typeface="Times New Roman" panose="02020603050405020304" pitchFamily="18" charset="0"/>
               </a:rPr>
               <a:t>B</a:t>
             </a:r>
@@ -3516,48 +3500,38 @@
                 <a:solidFill>
                   <a:srgbClr val="5B6C37"/>
                 </a:solidFill>
-                <a:latin typeface="Arial" panose="020B0604020202020204" pitchFamily="34" charset="0"/>
-                <a:cs typeface="Arial" panose="020B0604020202020204" pitchFamily="34" charset="0"/>
+                <a:latin typeface="Times New Roman" panose="02020603050405020304" pitchFamily="18" charset="0"/>
+                <a:cs typeface="Times New Roman" panose="02020603050405020304" pitchFamily="18" charset="0"/>
               </a:rPr>
-              <a:t> </a:t>
+              <a:t>, </a:t>
             </a:r>
             <a:r>
               <a:rPr lang="en-US" sz="600" b="1" dirty="0" smtClean="0">
                 <a:solidFill>
                   <a:srgbClr val="5B6C37"/>
                 </a:solidFill>
-                <a:latin typeface="Arial" panose="020B0604020202020204" pitchFamily="34" charset="0"/>
-                <a:cs typeface="Arial" panose="020B0604020202020204" pitchFamily="34" charset="0"/>
+                <a:latin typeface="Times New Roman" panose="02020603050405020304" pitchFamily="18" charset="0"/>
+                <a:cs typeface="Times New Roman" panose="02020603050405020304" pitchFamily="18" charset="0"/>
               </a:rPr>
-              <a:t>Dr. </a:t>
+              <a:t>Dr</a:t>
             </a:r>
             <a:r>
               <a:rPr lang="en-US" sz="600" b="1" dirty="0" smtClean="0">
                 <a:solidFill>
                   <a:srgbClr val="5B6C37"/>
                 </a:solidFill>
-                <a:latin typeface="Arial" panose="020B0604020202020204" pitchFamily="34" charset="0"/>
-                <a:cs typeface="Arial" panose="020B0604020202020204" pitchFamily="34" charset="0"/>
+                <a:latin typeface="Times New Roman" panose="02020603050405020304" pitchFamily="18" charset="0"/>
+                <a:cs typeface="Times New Roman" panose="02020603050405020304" pitchFamily="18" charset="0"/>
               </a:rPr>
-              <a:t>Gurumukh </a:t>
-            </a:r>
-            <a:r>
-              <a:rPr lang="en-US" sz="600" b="1" dirty="0" smtClean="0">
-                <a:solidFill>
-                  <a:srgbClr val="5B6C37"/>
-                </a:solidFill>
-                <a:latin typeface="Arial" panose="020B0604020202020204" pitchFamily="34" charset="0"/>
-                <a:cs typeface="Arial" panose="020B0604020202020204" pitchFamily="34" charset="0"/>
-              </a:rPr>
-              <a:t>Singh Colony,</a:t>
+              <a:t>. Gurumukh Singh Colony,</a:t>
             </a:r>
             <a:r>
               <a:rPr lang="en-US" sz="600" dirty="0" smtClean="0">
                 <a:solidFill>
                   <a:srgbClr val="5B6C37"/>
                 </a:solidFill>
-                <a:latin typeface="Arial" panose="020B0604020202020204" pitchFamily="34" charset="0"/>
-                <a:cs typeface="Arial" panose="020B0604020202020204" pitchFamily="34" charset="0"/>
+                <a:latin typeface="Times New Roman" panose="02020603050405020304" pitchFamily="18" charset="0"/>
+                <a:cs typeface="Times New Roman" panose="02020603050405020304" pitchFamily="18" charset="0"/>
               </a:rPr>
               <a:t/>
             </a:r>
@@ -3566,8 +3540,8 @@
                 <a:solidFill>
                   <a:srgbClr val="5B6C37"/>
                 </a:solidFill>
-                <a:latin typeface="Arial" panose="020B0604020202020204" pitchFamily="34" charset="0"/>
-                <a:cs typeface="Arial" panose="020B0604020202020204" pitchFamily="34" charset="0"/>
+                <a:latin typeface="Times New Roman" panose="02020603050405020304" pitchFamily="18" charset="0"/>
+                <a:cs typeface="Times New Roman" panose="02020603050405020304" pitchFamily="18" charset="0"/>
               </a:rPr>
             </a:br>
             <a:r>
@@ -3575,8 +3549,8 @@
                 <a:solidFill>
                   <a:srgbClr val="5B6C37"/>
                 </a:solidFill>
-                <a:latin typeface="Arial" panose="020B0604020202020204" pitchFamily="34" charset="0"/>
-                <a:cs typeface="Arial" panose="020B0604020202020204" pitchFamily="34" charset="0"/>
+                <a:latin typeface="Times New Roman" panose="02020603050405020304" pitchFamily="18" charset="0"/>
+                <a:cs typeface="Times New Roman" panose="02020603050405020304" pitchFamily="18" charset="0"/>
               </a:rPr>
               <a:t>Mandi Gobindgarh </a:t>
             </a:r>
@@ -3584,8 +3558,8 @@
               <a:solidFill>
                 <a:srgbClr val="5B6C37"/>
               </a:solidFill>
-              <a:latin typeface="Arial" panose="020B0604020202020204" pitchFamily="34" charset="0"/>
-              <a:cs typeface="Arial" panose="020B0604020202020204" pitchFamily="34" charset="0"/>
+              <a:latin typeface="Times New Roman" panose="02020603050405020304" pitchFamily="18" charset="0"/>
+              <a:cs typeface="Times New Roman" panose="02020603050405020304" pitchFamily="18" charset="0"/>
             </a:endParaRPr>
           </a:p>
         </p:txBody>
@@ -3598,8 +3572,8 @@
         </p:nvSpPr>
         <p:spPr>
           <a:xfrm>
-            <a:off x="1108904" y="694617"/>
-            <a:ext cx="701399" cy="276999"/>
+            <a:off x="1136729" y="1078940"/>
+            <a:ext cx="701399" cy="246221"/>
           </a:xfrm>
           <a:prstGeom prst="rect">
             <a:avLst/>
@@ -3613,17 +3587,17 @@
           <a:lstStyle/>
           <a:p>
             <a:r>
-              <a:rPr lang="en-US" sz="1200" dirty="0" smtClean="0">
+              <a:rPr lang="en-US" sz="1000" dirty="0" smtClean="0">
                 <a:solidFill>
-                  <a:srgbClr val="7E0000"/>
+                  <a:srgbClr val="7E603A"/>
                 </a:solidFill>
                 <a:latin typeface="Georgia" panose="02040502050405020303" pitchFamily="18" charset="0"/>
               </a:rPr>
               <a:t>Phone :</a:t>
             </a:r>
-            <a:endParaRPr lang="en-US" sz="1200" dirty="0">
+            <a:endParaRPr lang="en-US" sz="1000" dirty="0">
               <a:solidFill>
-                <a:srgbClr val="7E0000"/>
+                <a:srgbClr val="7E603A"/>
               </a:solidFill>
               <a:latin typeface="Georgia" panose="02040502050405020303" pitchFamily="18" charset="0"/>
             </a:endParaRPr>
@@ -3684,7 +3658,7 @@
         </p:nvSpPr>
         <p:spPr>
           <a:xfrm>
-            <a:off x="1108904" y="934760"/>
+            <a:off x="1123387" y="1286854"/>
             <a:ext cx="728084" cy="184666"/>
           </a:xfrm>
           <a:prstGeom prst="rect">
@@ -3769,7 +3743,18 @@
                 <a:ea typeface="Nirmala UI" pitchFamily="34" charset="-122"/>
                 <a:cs typeface="Nirmala UI" pitchFamily="34" charset="-120"/>
               </a:rPr>
-              <a:t>🌿   शुद्ध • सात्विक • शाकाहारी खाना  </a:t>
+              <a:t>🌿   </a:t>
+            </a:r>
+            <a:r>
+              <a:rPr lang="en-US" sz="800" b="1" dirty="0" err="1" smtClean="0">
+                <a:solidFill>
+                  <a:srgbClr val="466A32"/>
+                </a:solidFill>
+                <a:latin typeface="Nirmala UI" pitchFamily="34" charset="0"/>
+                <a:ea typeface="Nirmala UI" pitchFamily="34" charset="-122"/>
+                <a:cs typeface="Nirmala UI" pitchFamily="34" charset="-120"/>
+              </a:rPr>
+              <a:t>शुद्ध</a:t>
             </a:r>
             <a:r>
               <a:rPr lang="en-US" sz="800" b="1" dirty="0" smtClean="0">
@@ -3780,7 +3765,73 @@
                 <a:ea typeface="Nirmala UI" pitchFamily="34" charset="-122"/>
                 <a:cs typeface="Nirmala UI" pitchFamily="34" charset="-120"/>
               </a:rPr>
-              <a:t>🌿</a:t>
+              <a:t> </a:t>
+            </a:r>
+            <a:r>
+              <a:rPr lang="en-US" sz="800" b="1" dirty="0" smtClean="0">
+                <a:solidFill>
+                  <a:srgbClr val="466A32"/>
+                </a:solidFill>
+                <a:latin typeface="Nirmala UI" pitchFamily="34" charset="0"/>
+                <a:ea typeface="Nirmala UI" pitchFamily="34" charset="-122"/>
+                <a:cs typeface="Nirmala UI" pitchFamily="34" charset="-120"/>
+              </a:rPr>
+              <a:t>• </a:t>
+            </a:r>
+            <a:r>
+              <a:rPr lang="en-US" sz="800" b="1" dirty="0" err="1" smtClean="0">
+                <a:solidFill>
+                  <a:srgbClr val="466A32"/>
+                </a:solidFill>
+                <a:latin typeface="Nirmala UI" pitchFamily="34" charset="0"/>
+                <a:ea typeface="Nirmala UI" pitchFamily="34" charset="-122"/>
+                <a:cs typeface="Nirmala UI" pitchFamily="34" charset="-120"/>
+              </a:rPr>
+              <a:t>सात्विक</a:t>
+            </a:r>
+            <a:r>
+              <a:rPr lang="en-US" sz="800" b="1" dirty="0" smtClean="0">
+                <a:solidFill>
+                  <a:srgbClr val="466A32"/>
+                </a:solidFill>
+                <a:latin typeface="Nirmala UI" pitchFamily="34" charset="0"/>
+                <a:ea typeface="Nirmala UI" pitchFamily="34" charset="-122"/>
+                <a:cs typeface="Nirmala UI" pitchFamily="34" charset="-120"/>
+              </a:rPr>
+              <a:t> • </a:t>
+            </a:r>
+            <a:r>
+              <a:rPr lang="en-US" sz="800" b="1" dirty="0" err="1" smtClean="0">
+                <a:solidFill>
+                  <a:srgbClr val="466A32"/>
+                </a:solidFill>
+                <a:latin typeface="Nirmala UI" pitchFamily="34" charset="0"/>
+                <a:ea typeface="Nirmala UI" pitchFamily="34" charset="-122"/>
+                <a:cs typeface="Nirmala UI" pitchFamily="34" charset="-120"/>
+              </a:rPr>
+              <a:t>शाकाहारी</a:t>
+            </a:r>
+            <a:r>
+              <a:rPr lang="en-US" sz="800" b="1" dirty="0" smtClean="0">
+                <a:solidFill>
+                  <a:srgbClr val="466A32"/>
+                </a:solidFill>
+                <a:latin typeface="Nirmala UI" pitchFamily="34" charset="0"/>
+                <a:ea typeface="Nirmala UI" pitchFamily="34" charset="-122"/>
+                <a:cs typeface="Nirmala UI" pitchFamily="34" charset="-120"/>
+              </a:rPr>
+              <a:t> </a:t>
+            </a:r>
+            <a:r>
+              <a:rPr lang="en-US" sz="800" b="1" dirty="0" smtClean="0">
+                <a:solidFill>
+                  <a:srgbClr val="466A32"/>
+                </a:solidFill>
+                <a:latin typeface="Nirmala UI" pitchFamily="34" charset="0"/>
+                <a:ea typeface="Nirmala UI" pitchFamily="34" charset="-122"/>
+                <a:cs typeface="Nirmala UI" pitchFamily="34" charset="-120"/>
+              </a:rPr>
+              <a:t>खाना  🌿</a:t>
             </a:r>
             <a:endParaRPr lang="en-US" sz="800" dirty="0"/>
           </a:p>
@@ -3889,7 +3940,7 @@
         </p:blipFill>
         <p:spPr>
           <a:xfrm>
-            <a:off x="987990" y="748137"/>
+            <a:off x="972450" y="1108004"/>
             <a:ext cx="193558" cy="193558"/>
           </a:xfrm>
           <a:prstGeom prst="rect">

</xml_diff>

<commit_message>
New Folder is created for coding prupose of sattvik bhojan
</commit_message>
<xml_diff>
--- a/Presentation1.pptx
+++ b/Presentation1.pptx
@@ -244,7 +244,7 @@
           <a:p>
             <a:fld id="{84459CE5-3DCD-4F06-A7E5-92B988EAB955}" type="datetimeFigureOut">
               <a:rPr lang="en-US" smtClean="0"/>
-              <a:t>8/28/2026</a:t>
+              <a:t>9/5/2026</a:t>
             </a:fld>
             <a:endParaRPr lang="en-US" dirty="0"/>
           </a:p>
@@ -414,7 +414,7 @@
           <a:p>
             <a:fld id="{84459CE5-3DCD-4F06-A7E5-92B988EAB955}" type="datetimeFigureOut">
               <a:rPr lang="en-US" smtClean="0"/>
-              <a:t>8/28/2026</a:t>
+              <a:t>9/5/2026</a:t>
             </a:fld>
             <a:endParaRPr lang="en-US" dirty="0"/>
           </a:p>
@@ -594,7 +594,7 @@
           <a:p>
             <a:fld id="{84459CE5-3DCD-4F06-A7E5-92B988EAB955}" type="datetimeFigureOut">
               <a:rPr lang="en-US" smtClean="0"/>
-              <a:t>8/28/2026</a:t>
+              <a:t>9/5/2026</a:t>
             </a:fld>
             <a:endParaRPr lang="en-US" dirty="0"/>
           </a:p>
@@ -764,7 +764,7 @@
           <a:p>
             <a:fld id="{84459CE5-3DCD-4F06-A7E5-92B988EAB955}" type="datetimeFigureOut">
               <a:rPr lang="en-US" smtClean="0"/>
-              <a:t>8/28/2026</a:t>
+              <a:t>9/5/2026</a:t>
             </a:fld>
             <a:endParaRPr lang="en-US" dirty="0"/>
           </a:p>
@@ -1010,7 +1010,7 @@
           <a:p>
             <a:fld id="{84459CE5-3DCD-4F06-A7E5-92B988EAB955}" type="datetimeFigureOut">
               <a:rPr lang="en-US" smtClean="0"/>
-              <a:t>8/28/2026</a:t>
+              <a:t>9/5/2026</a:t>
             </a:fld>
             <a:endParaRPr lang="en-US" dirty="0"/>
           </a:p>
@@ -1242,7 +1242,7 @@
           <a:p>
             <a:fld id="{84459CE5-3DCD-4F06-A7E5-92B988EAB955}" type="datetimeFigureOut">
               <a:rPr lang="en-US" smtClean="0"/>
-              <a:t>8/28/2026</a:t>
+              <a:t>9/5/2026</a:t>
             </a:fld>
             <a:endParaRPr lang="en-US" dirty="0"/>
           </a:p>
@@ -1609,7 +1609,7 @@
           <a:p>
             <a:fld id="{84459CE5-3DCD-4F06-A7E5-92B988EAB955}" type="datetimeFigureOut">
               <a:rPr lang="en-US" smtClean="0"/>
-              <a:t>8/28/2026</a:t>
+              <a:t>9/5/2026</a:t>
             </a:fld>
             <a:endParaRPr lang="en-US" dirty="0"/>
           </a:p>
@@ -1727,7 +1727,7 @@
           <a:p>
             <a:fld id="{84459CE5-3DCD-4F06-A7E5-92B988EAB955}" type="datetimeFigureOut">
               <a:rPr lang="en-US" smtClean="0"/>
-              <a:t>8/28/2026</a:t>
+              <a:t>9/5/2026</a:t>
             </a:fld>
             <a:endParaRPr lang="en-US" dirty="0"/>
           </a:p>
@@ -1822,7 +1822,7 @@
           <a:p>
             <a:fld id="{84459CE5-3DCD-4F06-A7E5-92B988EAB955}" type="datetimeFigureOut">
               <a:rPr lang="en-US" smtClean="0"/>
-              <a:t>8/28/2026</a:t>
+              <a:t>9/5/2026</a:t>
             </a:fld>
             <a:endParaRPr lang="en-US" dirty="0"/>
           </a:p>
@@ -2099,7 +2099,7 @@
           <a:p>
             <a:fld id="{84459CE5-3DCD-4F06-A7E5-92B988EAB955}" type="datetimeFigureOut">
               <a:rPr lang="en-US" smtClean="0"/>
-              <a:t>8/28/2026</a:t>
+              <a:t>9/5/2026</a:t>
             </a:fld>
             <a:endParaRPr lang="en-US" dirty="0"/>
           </a:p>
@@ -2356,7 +2356,7 @@
           <a:p>
             <a:fld id="{84459CE5-3DCD-4F06-A7E5-92B988EAB955}" type="datetimeFigureOut">
               <a:rPr lang="en-US" smtClean="0"/>
-              <a:t>8/28/2026</a:t>
+              <a:t>9/5/2026</a:t>
             </a:fld>
             <a:endParaRPr lang="en-US" dirty="0"/>
           </a:p>
@@ -2569,7 +2569,7 @@
           <a:p>
             <a:fld id="{84459CE5-3DCD-4F06-A7E5-92B988EAB955}" type="datetimeFigureOut">
               <a:rPr lang="en-US" smtClean="0"/>
-              <a:t>8/28/2026</a:t>
+              <a:t>9/5/2026</a:t>
             </a:fld>
             <a:endParaRPr lang="en-US" dirty="0"/>
           </a:p>
@@ -3217,25 +3217,7 @@
                 </a:solidFill>
                 <a:latin typeface="Georgia" panose="02040502050405020303" pitchFamily="18" charset="0"/>
               </a:rPr>
-              <a:t>   </a:t>
-            </a:r>
-            <a:r>
-              <a:rPr lang="en-US" sz="800" i="1" dirty="0" smtClean="0">
-                <a:solidFill>
-                  <a:srgbClr val="7E603A"/>
-                </a:solidFill>
-                <a:latin typeface="Georgia" panose="02040502050405020303" pitchFamily="18" charset="0"/>
-              </a:rPr>
-              <a:t>Homemade </a:t>
-            </a:r>
-            <a:r>
-              <a:rPr lang="en-US" sz="800" i="1" dirty="0" smtClean="0">
-                <a:solidFill>
-                  <a:srgbClr val="7E603A"/>
-                </a:solidFill>
-                <a:latin typeface="Georgia" panose="02040502050405020303" pitchFamily="18" charset="0"/>
-              </a:rPr>
-              <a:t>food</a:t>
+              <a:t>   Homemade food</a:t>
             </a:r>
             <a:endParaRPr lang="en-US" sz="800" i="1" dirty="0">
               <a:solidFill>
@@ -3463,37 +3445,7 @@
                 <a:latin typeface="Times New Roman" panose="02020603050405020304" pitchFamily="18" charset="0"/>
                 <a:cs typeface="Times New Roman" panose="02020603050405020304" pitchFamily="18" charset="0"/>
               </a:rPr>
-              <a:t>House no. 129, Street no.: 3</a:t>
-            </a:r>
-            <a:r>
-              <a:rPr lang="en-US" sz="600" b="1" dirty="0" smtClean="0">
-                <a:solidFill>
-                  <a:srgbClr val="5B6C37"/>
-                </a:solidFill>
-                <a:latin typeface="Times New Roman" panose="02020603050405020304" pitchFamily="18" charset="0"/>
-                <a:cs typeface="Times New Roman" panose="02020603050405020304" pitchFamily="18" charset="0"/>
-              </a:rPr>
-              <a:t>, Sector</a:t>
-            </a:r>
-            <a:r>
-              <a:rPr lang="en-US" sz="600" b="1" dirty="0" smtClean="0">
-                <a:solidFill>
-                  <a:srgbClr val="5B6C37"/>
-                </a:solidFill>
-                <a:latin typeface="Times New Roman" panose="02020603050405020304" pitchFamily="18" charset="0"/>
-                <a:cs typeface="Times New Roman" panose="02020603050405020304" pitchFamily="18" charset="0"/>
-              </a:rPr>
-              <a:t>: 24, Block: </a:t>
-            </a:r>
-            <a:r>
-              <a:rPr lang="en-US" sz="600" b="1" dirty="0" smtClean="0">
-                <a:solidFill>
-                  <a:srgbClr val="5B6C37"/>
-                </a:solidFill>
-                <a:latin typeface="Times New Roman" panose="02020603050405020304" pitchFamily="18" charset="0"/>
-                <a:cs typeface="Times New Roman" panose="02020603050405020304" pitchFamily="18" charset="0"/>
-              </a:rPr>
-              <a:t>B</a:t>
+              <a:t>House no. 129, Street no.: 3, Sector: 24, Block: B</a:t>
             </a:r>
             <a:r>
               <a:rPr lang="en-US" sz="600" dirty="0" smtClean="0">
@@ -3513,17 +3465,7 @@
                 <a:latin typeface="Times New Roman" panose="02020603050405020304" pitchFamily="18" charset="0"/>
                 <a:cs typeface="Times New Roman" panose="02020603050405020304" pitchFamily="18" charset="0"/>
               </a:rPr>
-              <a:t>Dr</a:t>
-            </a:r>
-            <a:r>
-              <a:rPr lang="en-US" sz="600" b="1" dirty="0" smtClean="0">
-                <a:solidFill>
-                  <a:srgbClr val="5B6C37"/>
-                </a:solidFill>
-                <a:latin typeface="Times New Roman" panose="02020603050405020304" pitchFamily="18" charset="0"/>
-                <a:cs typeface="Times New Roman" panose="02020603050405020304" pitchFamily="18" charset="0"/>
-              </a:rPr>
-              <a:t>. Gurumukh Singh Colony,</a:t>
+              <a:t>Dr. Gurumukh Singh Colony,</a:t>
             </a:r>
             <a:r>
               <a:rPr lang="en-US" sz="600" dirty="0" smtClean="0">
@@ -3658,8 +3600,8 @@
         </p:nvSpPr>
         <p:spPr>
           <a:xfrm>
-            <a:off x="1123387" y="1286854"/>
-            <a:ext cx="728084" cy="184666"/>
+            <a:off x="1190948" y="1272314"/>
+            <a:ext cx="728084" cy="276999"/>
           </a:xfrm>
           <a:prstGeom prst="rect">
             <a:avLst/>
@@ -3671,6 +3613,18 @@
             <a:spAutoFit/>
           </a:bodyPr>
           <a:lstStyle/>
+          <a:p>
+            <a:r>
+              <a:rPr lang="en-US" sz="600" b="1" dirty="0">
+                <a:solidFill>
+                  <a:srgbClr val="5B6937"/>
+                </a:solidFill>
+                <a:latin typeface="Times New Roman" panose="02020603050405020304" pitchFamily="18" charset="0"/>
+                <a:cs typeface="Times New Roman" panose="02020603050405020304" pitchFamily="18" charset="0"/>
+              </a:rPr>
+              <a:t>+91 90416 25149</a:t>
+            </a:r>
+          </a:p>
           <a:p>
             <a:r>
               <a:rPr lang="en-US" sz="600" b="1" dirty="0" smtClean="0">
@@ -3680,15 +3634,28 @@
                 <a:latin typeface="Times New Roman" panose="02020603050405020304" pitchFamily="18" charset="0"/>
                 <a:cs typeface="Times New Roman" panose="02020603050405020304" pitchFamily="18" charset="0"/>
               </a:rPr>
-              <a:t>+91 90416 25149</a:t>
-            </a:r>
-            <a:endParaRPr lang="en-US" sz="600" b="1" dirty="0">
-              <a:solidFill>
-                <a:srgbClr val="5B6937"/>
-              </a:solidFill>
-              <a:latin typeface="Times New Roman" panose="02020603050405020304" pitchFamily="18" charset="0"/>
-              <a:cs typeface="Times New Roman" panose="02020603050405020304" pitchFamily="18" charset="0"/>
-            </a:endParaRPr>
+              <a:t>+</a:t>
+            </a:r>
+            <a:r>
+              <a:rPr lang="en-US" sz="600" b="1" dirty="0" smtClean="0">
+                <a:solidFill>
+                  <a:srgbClr val="5B6937"/>
+                </a:solidFill>
+                <a:latin typeface="Times New Roman" panose="02020603050405020304" pitchFamily="18" charset="0"/>
+                <a:cs typeface="Times New Roman" panose="02020603050405020304" pitchFamily="18" charset="0"/>
+              </a:rPr>
+              <a:t>91 </a:t>
+            </a:r>
+            <a:r>
+              <a:rPr lang="en-US" sz="600" b="1" dirty="0" smtClean="0">
+                <a:solidFill>
+                  <a:srgbClr val="5B6937"/>
+                </a:solidFill>
+                <a:latin typeface="Times New Roman" panose="02020603050405020304" pitchFamily="18" charset="0"/>
+                <a:cs typeface="Times New Roman" panose="02020603050405020304" pitchFamily="18" charset="0"/>
+              </a:rPr>
+              <a:t>95015 89847</a:t>
+            </a:r>
           </a:p>
         </p:txBody>
       </p:sp>
@@ -3765,18 +3732,7 @@
                 <a:ea typeface="Nirmala UI" pitchFamily="34" charset="-122"/>
                 <a:cs typeface="Nirmala UI" pitchFamily="34" charset="-120"/>
               </a:rPr>
-              <a:t> </a:t>
-            </a:r>
-            <a:r>
-              <a:rPr lang="en-US" sz="800" b="1" dirty="0" smtClean="0">
-                <a:solidFill>
-                  <a:srgbClr val="466A32"/>
-                </a:solidFill>
-                <a:latin typeface="Nirmala UI" pitchFamily="34" charset="0"/>
-                <a:ea typeface="Nirmala UI" pitchFamily="34" charset="-122"/>
-                <a:cs typeface="Nirmala UI" pitchFamily="34" charset="-120"/>
-              </a:rPr>
-              <a:t>• </a:t>
+              <a:t> • </a:t>
             </a:r>
             <a:r>
               <a:rPr lang="en-US" sz="800" b="1" dirty="0" err="1" smtClean="0">
@@ -3820,18 +3776,7 @@
                 <a:ea typeface="Nirmala UI" pitchFamily="34" charset="-122"/>
                 <a:cs typeface="Nirmala UI" pitchFamily="34" charset="-120"/>
               </a:rPr>
-              <a:t> </a:t>
-            </a:r>
-            <a:r>
-              <a:rPr lang="en-US" sz="800" b="1" dirty="0" smtClean="0">
-                <a:solidFill>
-                  <a:srgbClr val="466A32"/>
-                </a:solidFill>
-                <a:latin typeface="Nirmala UI" pitchFamily="34" charset="0"/>
-                <a:ea typeface="Nirmala UI" pitchFamily="34" charset="-122"/>
-                <a:cs typeface="Nirmala UI" pitchFamily="34" charset="-120"/>
-              </a:rPr>
-              <a:t>खाना  🌿</a:t>
+              <a:t> खाना  🌿</a:t>
             </a:r>
             <a:endParaRPr lang="en-US" sz="800" dirty="0"/>
           </a:p>

</xml_diff>